<commit_message>
Replace Claude Opus 5.5 mentions with a.i. across site, blog and explainer source
Co-Authored-By: Claude Opus 5.5 <noreply@anthropic.com>
Claude-Session: https://claude.ai/code/session_01WZwv6jMsJjrGkXjtLTGBdR
</commit_message>
<xml_diff>
--- a/studio/examples/explainer-v3/input-deck.pptx
+++ b/studio/examples/explainer-v3/input-deck.pptx
@@ -832,7 +832,7 @@
           <a:lstStyle/>
           <a:p>
             <a:r>
-              <a:t>In terms of plans, Basic exports have a watermark on them. Pro is from A$29 a month and includes 10 Opus-directed videos with no watermark.</a:t>
+              <a:t>In terms of plans, Basic exports have a watermark on them. Pro is from A$29 a month and includes 10 a.i.-directed videos with no watermark.</a:t>
             </a:r>
           </a:p>
         </p:txBody>
@@ -4182,7 +4182,7 @@
           </a:p>
           <a:p>
             <a:r>
-              <a:t>Pro includes 10 Opus-directed videos, no watermark</a:t>
+              <a:t>Pro includes 10 a.i.-directed videos, no watermark</a:t>
             </a:r>
           </a:p>
         </p:txBody>

</xml_diff>